<commit_message>
Added error handling to tasks.py and main.py.
</commit_message>
<xml_diff>
--- a/slides.pptx
+++ b/slides.pptx
@@ -5361,7 +5361,7 @@
               </a:defRPr>
             </a:pPr>
             <a:r>
-              <a:t>  .claude/hooks/check-secrets.sh checks for password/token patterns</a:t>
+              <a:t>  .claude/hooks/block-hardcoded-keys.sh checks for password/token patterns</a:t>
             </a:r>
           </a:p>
           <a:p>
@@ -11482,22 +11482,6 @@
             </a:pPr>
             <a:r>
               <a:t>Docs: https://code.claude.com/docs/</a:t>
-            </a:r>
-          </a:p>
-          <a:p>
-            <a:pPr>
-              <a:spcBef>
-                <a:spcPts val="800"/>
-              </a:spcBef>
-              <a:defRPr sz="1800" b="0">
-                <a:solidFill>
-                  <a:srgbClr val="E0E0E0"/>
-                </a:solidFill>
-                <a:latin typeface="Calibri"/>
-              </a:defRPr>
-            </a:pPr>
-            <a:r>
-              <a:t>Cheat sheet: CHEATSHEET.md in this repo</a:t>
             </a:r>
           </a:p>
           <a:p>

</xml_diff>